<commit_message>
feat: added week 3 lecture notes
</commit_message>
<xml_diff>
--- a/Modern-Makine-Ogrenmesi-Mimarisi.pptx
+++ b/Modern-Makine-Ogrenmesi-Mimarisi.pptx
@@ -11,8 +11,8 @@
     <p:sldId id="256" r:id="rId2"/>
     <p:sldId id="270" r:id="rId3"/>
     <p:sldId id="258" r:id="rId4"/>
-    <p:sldId id="259" r:id="rId5"/>
-    <p:sldId id="260" r:id="rId6"/>
+    <p:sldId id="260" r:id="rId5"/>
+    <p:sldId id="259" r:id="rId6"/>
     <p:sldId id="261" r:id="rId7"/>
     <p:sldId id="262" r:id="rId8"/>
     <p:sldId id="263" r:id="rId9"/>
@@ -7338,6 +7338,897 @@
 
 <file path=ppt/slides/slide4.xml><?xml version="1.0" encoding="utf-8"?>
 <p:sld xmlns:a="http://schemas.openxmlformats.org/drawingml/2006/main" xmlns:r="http://schemas.openxmlformats.org/officeDocument/2006/relationships" xmlns:p="http://schemas.openxmlformats.org/presentationml/2006/main">
+  <p:cSld name="Slide 5">
+    <p:spTree>
+      <p:nvGrpSpPr>
+        <p:cNvPr id="1" name=""/>
+        <p:cNvGrpSpPr/>
+        <p:nvPr/>
+      </p:nvGrpSpPr>
+      <p:grpSpPr>
+        <a:xfrm>
+          <a:off x="0" y="0"/>
+          <a:ext cx="0" cy="0"/>
+          <a:chOff x="0" y="0"/>
+          <a:chExt cx="0" cy="0"/>
+        </a:xfrm>
+      </p:grpSpPr>
+      <p:sp>
+        <p:nvSpPr>
+          <p:cNvPr id="2" name="Text 0"/>
+          <p:cNvSpPr/>
+          <p:nvPr/>
+        </p:nvSpPr>
+        <p:spPr>
+          <a:xfrm>
+            <a:off x="661475" y="684212"/>
+            <a:ext cx="10868745" cy="553740"/>
+          </a:xfrm>
+          <a:prstGeom prst="rect">
+            <a:avLst/>
+          </a:prstGeom>
+          <a:noFill/>
+          <a:ln/>
+        </p:spPr>
+        <p:txBody>
+          <a:bodyPr wrap="none" lIns="0" tIns="0" rIns="0" bIns="0" rtlCol="0" anchor="t"/>
+          <a:lstStyle/>
+          <a:p>
+            <a:pPr marL="0" indent="0" algn="l">
+              <a:lnSpc>
+                <a:spcPct val="104000"/>
+              </a:lnSpc>
+              <a:buNone/>
+            </a:pPr>
+            <a:r>
+              <a:rPr lang="en-US" sz="3450" dirty="0">
+                <a:solidFill>
+                  <a:srgbClr val="201B18"/>
+                </a:solidFill>
+                <a:latin typeface="Platypi Medium" pitchFamily="34" charset="0"/>
+                <a:ea typeface="Platypi Medium" pitchFamily="34" charset="-122"/>
+                <a:cs typeface="Platypi Medium" pitchFamily="34" charset="-120"/>
+              </a:rPr>
+              <a:t>Haftalık Ders Planı: Detaylı Yol Haritası</a:t>
+            </a:r>
+            <a:endParaRPr lang="en-US" sz="3450" dirty="0"/>
+          </a:p>
+        </p:txBody>
+      </p:sp>
+      <p:sp>
+        <p:nvSpPr>
+          <p:cNvPr id="3" name="Text 1"/>
+          <p:cNvSpPr/>
+          <p:nvPr/>
+        </p:nvSpPr>
+        <p:spPr>
+          <a:xfrm>
+            <a:off x="661475" y="1653183"/>
+            <a:ext cx="5218280" cy="276920"/>
+          </a:xfrm>
+          <a:prstGeom prst="rect">
+            <a:avLst/>
+          </a:prstGeom>
+          <a:noFill/>
+          <a:ln/>
+        </p:spPr>
+        <p:txBody>
+          <a:bodyPr wrap="none" lIns="0" tIns="0" rIns="0" bIns="0" rtlCol="0" anchor="t"/>
+          <a:lstStyle/>
+          <a:p>
+            <a:pPr marL="0" indent="0" algn="l">
+              <a:lnSpc>
+                <a:spcPct val="104000"/>
+              </a:lnSpc>
+              <a:buNone/>
+            </a:pPr>
+            <a:r>
+              <a:rPr lang="en-US" sz="1700" dirty="0">
+                <a:solidFill>
+                  <a:srgbClr val="201B18"/>
+                </a:solidFill>
+                <a:latin typeface="Platypi Medium" pitchFamily="34" charset="0"/>
+                <a:ea typeface="Platypi Medium" pitchFamily="34" charset="-122"/>
+                <a:cs typeface="Platypi Medium" pitchFamily="34" charset="-120"/>
+              </a:rPr>
+              <a:t>Aşama 1: Temel Geliştirme (1-4 Haftalar)</a:t>
+            </a:r>
+            <a:endParaRPr lang="en-US" sz="1700" dirty="0"/>
+          </a:p>
+        </p:txBody>
+      </p:sp>
+      <p:sp>
+        <p:nvSpPr>
+          <p:cNvPr id="4" name="Text 2"/>
+          <p:cNvSpPr/>
+          <p:nvPr/>
+        </p:nvSpPr>
+        <p:spPr>
+          <a:xfrm>
+            <a:off x="661475" y="2096195"/>
+            <a:ext cx="5218280" cy="4019352"/>
+          </a:xfrm>
+          <a:prstGeom prst="rect">
+            <a:avLst/>
+          </a:prstGeom>
+          <a:noFill/>
+          <a:ln/>
+        </p:spPr>
+        <p:txBody>
+          <a:bodyPr wrap="square" lIns="0" tIns="0" rIns="0" bIns="0" rtlCol="0" anchor="t">
+            <a:normAutofit/>
+          </a:bodyPr>
+          <a:lstStyle/>
+          <a:p>
+            <a:pPr marL="274320" indent="-274320" algn="l">
+              <a:lnSpc>
+                <a:spcPct val="129000"/>
+              </a:lnSpc>
+              <a:buSzPct val="100000"/>
+              <a:buFont typeface="+mj-lt"/>
+              <a:buAutoNum type="arabicPeriod"/>
+            </a:pPr>
+            <a:r>
+              <a:rPr lang="en-US" sz="1350" dirty="0">
+                <a:solidFill>
+                  <a:srgbClr val="504C49"/>
+                </a:solidFill>
+                <a:latin typeface="Source Serif 4" pitchFamily="34" charset="0"/>
+                <a:ea typeface="Source Serif 4" pitchFamily="34" charset="-122"/>
+                <a:cs typeface="Source Serif 4" pitchFamily="34" charset="-120"/>
+              </a:rPr>
+              <a:t>             </a:t>
+            </a:r>
+            <a:r>
+              <a:rPr lang="en-US" sz="1350" b="1" dirty="0">
+                <a:solidFill>
+                  <a:srgbClr val="504C49"/>
+                </a:solidFill>
+                <a:latin typeface="Source Serif 4 Bold" pitchFamily="34" charset="0"/>
+                <a:ea typeface="Source Serif 4 Bold" pitchFamily="34" charset="-122"/>
+                <a:cs typeface="Source Serif 4 Bold" pitchFamily="34" charset="-120"/>
+              </a:rPr>
+              <a:t>Hafta 1 (Giriş ve ML Yaşam Döngüsü):</a:t>
+            </a:r>
+            <a:r>
+              <a:rPr lang="en-US" sz="1350" dirty="0">
+                <a:solidFill>
+                  <a:srgbClr val="504C49"/>
+                </a:solidFill>
+                <a:latin typeface="Source Serif 4" pitchFamily="34" charset="0"/>
+                <a:ea typeface="Source Serif 4" pitchFamily="34" charset="-122"/>
+                <a:cs typeface="Source Serif 4" pitchFamily="34" charset="-120"/>
+              </a:rPr>
+              <a:t> SDLC vs MLOps, Agile Veri Bilimi, Notebook'tan Production'a geçiş, modüler .py ve cookiecutter proje mimarisi kurulumu.           </a:t>
+            </a:r>
+            <a:endParaRPr lang="en-US" sz="1350" dirty="0"/>
+          </a:p>
+          <a:p>
+            <a:pPr marL="274320" indent="-274320" algn="l">
+              <a:lnSpc>
+                <a:spcPct val="129000"/>
+              </a:lnSpc>
+              <a:buSzPct val="100000"/>
+              <a:buFont typeface="+mj-lt"/>
+              <a:buAutoNum type="arabicPeriod" startAt="2"/>
+            </a:pPr>
+            <a:r>
+              <a:rPr lang="en-US" sz="1350" dirty="0">
+                <a:solidFill>
+                  <a:srgbClr val="504C49"/>
+                </a:solidFill>
+                <a:latin typeface="Source Serif 4" pitchFamily="34" charset="0"/>
+                <a:ea typeface="Source Serif 4" pitchFamily="34" charset="-122"/>
+                <a:cs typeface="Source Serif 4" pitchFamily="34" charset="-120"/>
+              </a:rPr>
+              <a:t>             </a:t>
+            </a:r>
+            <a:r>
+              <a:rPr lang="en-US" sz="1350" b="1" dirty="0">
+                <a:solidFill>
+                  <a:srgbClr val="504C49"/>
+                </a:solidFill>
+                <a:latin typeface="Source Serif 4 Bold" pitchFamily="34" charset="0"/>
+                <a:ea typeface="Source Serif 4 Bold" pitchFamily="34" charset="-122"/>
+                <a:cs typeface="Source Serif 4 Bold" pitchFamily="34" charset="-120"/>
+              </a:rPr>
+              <a:t>Hafta 2 (Veri Mühendisliği ve Feature Store):</a:t>
+            </a:r>
+            <a:r>
+              <a:rPr lang="en-US" sz="1350" dirty="0">
+                <a:solidFill>
+                  <a:srgbClr val="504C49"/>
+                </a:solidFill>
+                <a:latin typeface="Source Serif 4" pitchFamily="34" charset="0"/>
+                <a:ea typeface="Source Serif 4" pitchFamily="34" charset="-122"/>
+                <a:cs typeface="Source Serif 4" pitchFamily="34" charset="-120"/>
+              </a:rPr>
+              <a:t> ETL/ELT süreçleri, Feature Store (Online/Offline) ve Train-Serve Skew engelleme.           </a:t>
+            </a:r>
+            <a:endParaRPr lang="en-US" sz="1350" dirty="0"/>
+          </a:p>
+          <a:p>
+            <a:pPr marL="274320" indent="-274320" algn="l">
+              <a:lnSpc>
+                <a:spcPct val="129000"/>
+              </a:lnSpc>
+              <a:buSzPct val="100000"/>
+              <a:buFont typeface="+mj-lt"/>
+              <a:buAutoNum type="arabicPeriod" startAt="3"/>
+            </a:pPr>
+            <a:r>
+              <a:rPr lang="en-US" sz="1350" dirty="0">
+                <a:solidFill>
+                  <a:srgbClr val="504C49"/>
+                </a:solidFill>
+                <a:latin typeface="Source Serif 4" pitchFamily="34" charset="0"/>
+                <a:ea typeface="Source Serif 4" pitchFamily="34" charset="-122"/>
+                <a:cs typeface="Source Serif 4" pitchFamily="34" charset="-120"/>
+              </a:rPr>
+              <a:t>             </a:t>
+            </a:r>
+            <a:r>
+              <a:rPr lang="en-US" sz="1350" b="1" dirty="0">
+                <a:solidFill>
+                  <a:srgbClr val="504C49"/>
+                </a:solidFill>
+                <a:latin typeface="Source Serif 4 Bold" pitchFamily="34" charset="0"/>
+                <a:ea typeface="Source Serif 4 Bold" pitchFamily="34" charset="-122"/>
+                <a:cs typeface="Source Serif 4 Bold" pitchFamily="34" charset="-120"/>
+              </a:rPr>
+              <a:t>Hafta 3 (İleri Seviye Algoritmalar - I):</a:t>
+            </a:r>
+            <a:r>
+              <a:rPr lang="en-US" sz="1350" dirty="0">
+                <a:solidFill>
+                  <a:srgbClr val="504C49"/>
+                </a:solidFill>
+                <a:latin typeface="Source Serif 4" pitchFamily="34" charset="0"/>
+                <a:ea typeface="Source Serif 4" pitchFamily="34" charset="-122"/>
+                <a:cs typeface="Source Serif 4" pitchFamily="34" charset="-120"/>
+              </a:rPr>
+              <a:t> Gradient Boosting (XGBoost vs. LightGBM), Sınıf Dengesizliği, Zaman Serisi Bölmesi (Time-Series Split) ve Optuna ile Bayesian Hiper-parametre Optimizasyonu. </a:t>
+            </a:r>
+            <a:endParaRPr lang="en-US" sz="1350" dirty="0"/>
+          </a:p>
+          <a:p>
+            <a:pPr marL="274320" indent="-274320" algn="l">
+              <a:lnSpc>
+                <a:spcPct val="129000"/>
+              </a:lnSpc>
+              <a:buSzPct val="100000"/>
+              <a:buFont typeface="+mj-lt"/>
+              <a:buAutoNum type="arabicPeriod" startAt="4"/>
+            </a:pPr>
+            <a:r>
+              <a:rPr lang="en-US" sz="1350" dirty="0">
+                <a:solidFill>
+                  <a:srgbClr val="504C49"/>
+                </a:solidFill>
+                <a:latin typeface="Source Serif 4" pitchFamily="34" charset="0"/>
+                <a:ea typeface="Source Serif 4" pitchFamily="34" charset="-122"/>
+                <a:cs typeface="Source Serif 4" pitchFamily="34" charset="-120"/>
+              </a:rPr>
+              <a:t>             </a:t>
+            </a:r>
+            <a:r>
+              <a:rPr lang="en-US" sz="1350" b="1" dirty="0">
+                <a:solidFill>
+                  <a:srgbClr val="504C49"/>
+                </a:solidFill>
+                <a:latin typeface="Source Serif 4 Bold" pitchFamily="34" charset="0"/>
+                <a:ea typeface="Source Serif 4 Bold" pitchFamily="34" charset="-122"/>
+                <a:cs typeface="Source Serif 4 Bold" pitchFamily="34" charset="-120"/>
+              </a:rPr>
+              <a:t>Hafta 4 (İleri Seviye Algoritmalar - II):</a:t>
+            </a:r>
+            <a:r>
+              <a:rPr lang="en-US" sz="1350" dirty="0">
+                <a:solidFill>
+                  <a:srgbClr val="504C49"/>
+                </a:solidFill>
+                <a:latin typeface="Source Serif 4" pitchFamily="34" charset="0"/>
+                <a:ea typeface="Source Serif 4" pitchFamily="34" charset="-122"/>
+                <a:cs typeface="Source Serif 4" pitchFamily="34" charset="-120"/>
+              </a:rPr>
+              <a:t> Yüksek kardinaliteli kategorik veriler, CatBoost (Ordered Boosting), Stacking ve Blending ensemble mimarileri kodlama.           </a:t>
+            </a:r>
+            <a:endParaRPr lang="en-US" sz="1350" dirty="0"/>
+          </a:p>
+        </p:txBody>
+      </p:sp>
+      <p:sp>
+        <p:nvSpPr>
+          <p:cNvPr id="5" name="Text 3"/>
+          <p:cNvSpPr/>
+          <p:nvPr/>
+        </p:nvSpPr>
+        <p:spPr>
+          <a:xfrm>
+            <a:off x="6318290" y="1653183"/>
+            <a:ext cx="5218280" cy="553839"/>
+          </a:xfrm>
+          <a:prstGeom prst="rect">
+            <a:avLst/>
+          </a:prstGeom>
+          <a:noFill/>
+          <a:ln/>
+        </p:spPr>
+        <p:txBody>
+          <a:bodyPr wrap="square" lIns="0" tIns="0" rIns="0" bIns="0" rtlCol="0" anchor="t">
+            <a:normAutofit/>
+          </a:bodyPr>
+          <a:lstStyle/>
+          <a:p>
+            <a:pPr marL="0" indent="0" algn="l">
+              <a:lnSpc>
+                <a:spcPct val="104000"/>
+              </a:lnSpc>
+              <a:buNone/>
+            </a:pPr>
+            <a:r>
+              <a:rPr lang="en-US" sz="1700" dirty="0">
+                <a:solidFill>
+                  <a:srgbClr val="201B18"/>
+                </a:solidFill>
+                <a:latin typeface="Platypi Medium" pitchFamily="34" charset="0"/>
+                <a:ea typeface="Platypi Medium" pitchFamily="34" charset="-122"/>
+                <a:cs typeface="Platypi Medium" pitchFamily="34" charset="-120"/>
+              </a:rPr>
+              <a:t>Aşama 2: MLOps, Deployment ve Operasyon (5-15 Haftalar Taslağı)</a:t>
+            </a:r>
+            <a:endParaRPr lang="en-US" sz="1700" dirty="0"/>
+          </a:p>
+        </p:txBody>
+      </p:sp>
+      <p:sp>
+        <p:nvSpPr>
+          <p:cNvPr id="6" name="Text 4"/>
+          <p:cNvSpPr/>
+          <p:nvPr/>
+        </p:nvSpPr>
+        <p:spPr>
+          <a:xfrm>
+            <a:off x="6318290" y="2373114"/>
+            <a:ext cx="5218280" cy="3602434"/>
+          </a:xfrm>
+          <a:prstGeom prst="rect">
+            <a:avLst/>
+          </a:prstGeom>
+          <a:noFill/>
+          <a:ln/>
+        </p:spPr>
+        <p:txBody>
+          <a:bodyPr wrap="square" lIns="0" tIns="0" rIns="0" bIns="0" rtlCol="0" anchor="t">
+            <a:normAutofit/>
+          </a:bodyPr>
+          <a:lstStyle/>
+          <a:p>
+            <a:pPr marL="274320" indent="-274320" algn="l">
+              <a:lnSpc>
+                <a:spcPct val="129000"/>
+              </a:lnSpc>
+              <a:buSzPct val="100000"/>
+              <a:buFont typeface="+mj-lt"/>
+              <a:buAutoNum type="arabicPeriod"/>
+            </a:pPr>
+            <a:r>
+              <a:rPr lang="en-US" sz="1350" dirty="0">
+                <a:solidFill>
+                  <a:srgbClr val="504C49"/>
+                </a:solidFill>
+                <a:latin typeface="Source Serif 4" pitchFamily="34" charset="0"/>
+                <a:ea typeface="Source Serif 4" pitchFamily="34" charset="-122"/>
+                <a:cs typeface="Source Serif 4" pitchFamily="34" charset="-120"/>
+              </a:rPr>
+              <a:t>             </a:t>
+            </a:r>
+            <a:r>
+              <a:rPr lang="en-US" sz="1350" b="1" dirty="0">
+                <a:solidFill>
+                  <a:srgbClr val="504C49"/>
+                </a:solidFill>
+                <a:latin typeface="Source Serif 4 Bold" pitchFamily="34" charset="0"/>
+                <a:ea typeface="Source Serif 4 Bold" pitchFamily="34" charset="-122"/>
+                <a:cs typeface="Source Serif 4 Bold" pitchFamily="34" charset="-120"/>
+              </a:rPr>
+              <a:t>Hafta 5:</a:t>
+            </a:r>
+            <a:r>
+              <a:rPr lang="en-US" sz="1350" dirty="0">
+                <a:solidFill>
+                  <a:srgbClr val="504C49"/>
+                </a:solidFill>
+                <a:latin typeface="Source Serif 4" pitchFamily="34" charset="0"/>
+                <a:ea typeface="Source Serif 4" pitchFamily="34" charset="-122"/>
+                <a:cs typeface="Source Serif 4" pitchFamily="34" charset="-120"/>
+              </a:rPr>
+              <a:t> Mimari Tasarım (Batch vs. Real-time)           </a:t>
+            </a:r>
+            <a:endParaRPr lang="en-US" sz="1350" dirty="0"/>
+          </a:p>
+          <a:p>
+            <a:pPr marL="274320" indent="-274320" algn="l">
+              <a:lnSpc>
+                <a:spcPct val="129000"/>
+              </a:lnSpc>
+              <a:buSzPct val="100000"/>
+              <a:buFont typeface="+mj-lt"/>
+              <a:buAutoNum type="arabicPeriod" startAt="2"/>
+            </a:pPr>
+            <a:r>
+              <a:rPr lang="en-US" sz="1350" dirty="0">
+                <a:solidFill>
+                  <a:srgbClr val="504C49"/>
+                </a:solidFill>
+                <a:latin typeface="Source Serif 4" pitchFamily="34" charset="0"/>
+                <a:ea typeface="Source Serif 4" pitchFamily="34" charset="-122"/>
+                <a:cs typeface="Source Serif 4" pitchFamily="34" charset="-120"/>
+              </a:rPr>
+              <a:t>             </a:t>
+            </a:r>
+            <a:r>
+              <a:rPr lang="en-US" sz="1350" b="1" dirty="0">
+                <a:solidFill>
+                  <a:srgbClr val="504C49"/>
+                </a:solidFill>
+                <a:latin typeface="Source Serif 4 Bold" pitchFamily="34" charset="0"/>
+                <a:ea typeface="Source Serif 4 Bold" pitchFamily="34" charset="-122"/>
+                <a:cs typeface="Source Serif 4 Bold" pitchFamily="34" charset="-120"/>
+              </a:rPr>
+              <a:t>Hafta 6:</a:t>
+            </a:r>
+            <a:r>
+              <a:rPr lang="en-US" sz="1350" dirty="0">
+                <a:solidFill>
+                  <a:srgbClr val="504C49"/>
+                </a:solidFill>
+                <a:latin typeface="Source Serif 4" pitchFamily="34" charset="0"/>
+                <a:ea typeface="Source Serif 4" pitchFamily="34" charset="-122"/>
+                <a:cs typeface="Source Serif 4" pitchFamily="34" charset="-120"/>
+              </a:rPr>
+              <a:t> Deney Takibi ve MLflow           </a:t>
+            </a:r>
+            <a:endParaRPr lang="en-US" sz="1350" dirty="0"/>
+          </a:p>
+          <a:p>
+            <a:pPr marL="274320" indent="-274320" algn="l">
+              <a:lnSpc>
+                <a:spcPct val="129000"/>
+              </a:lnSpc>
+              <a:buSzPct val="100000"/>
+              <a:buFont typeface="+mj-lt"/>
+              <a:buAutoNum type="arabicPeriod" startAt="3"/>
+            </a:pPr>
+            <a:r>
+              <a:rPr lang="en-US" sz="1350" dirty="0">
+                <a:solidFill>
+                  <a:srgbClr val="504C49"/>
+                </a:solidFill>
+                <a:latin typeface="Source Serif 4" pitchFamily="34" charset="0"/>
+                <a:ea typeface="Source Serif 4" pitchFamily="34" charset="-122"/>
+                <a:cs typeface="Source Serif 4" pitchFamily="34" charset="-120"/>
+              </a:rPr>
+              <a:t>             </a:t>
+            </a:r>
+            <a:r>
+              <a:rPr lang="en-US" sz="1350" b="1" dirty="0">
+                <a:solidFill>
+                  <a:srgbClr val="504C49"/>
+                </a:solidFill>
+                <a:latin typeface="Source Serif 4 Bold" pitchFamily="34" charset="0"/>
+                <a:ea typeface="Source Serif 4 Bold" pitchFamily="34" charset="-122"/>
+                <a:cs typeface="Source Serif 4 Bold" pitchFamily="34" charset="-120"/>
+              </a:rPr>
+              <a:t>Hafta 7:</a:t>
+            </a:r>
+            <a:r>
+              <a:rPr lang="en-US" sz="1350" dirty="0">
+                <a:solidFill>
+                  <a:srgbClr val="504C49"/>
+                </a:solidFill>
+                <a:latin typeface="Source Serif 4" pitchFamily="34" charset="0"/>
+                <a:ea typeface="Source Serif 4" pitchFamily="34" charset="-122"/>
+                <a:cs typeface="Source Serif 4" pitchFamily="34" charset="-120"/>
+              </a:rPr>
+              <a:t> Sınıflandırma/Regresyon İleri Konular           </a:t>
+            </a:r>
+            <a:endParaRPr lang="en-US" sz="1350" dirty="0"/>
+          </a:p>
+          <a:p>
+            <a:pPr marL="274320" indent="-274320" algn="l">
+              <a:lnSpc>
+                <a:spcPct val="129000"/>
+              </a:lnSpc>
+              <a:buSzPct val="100000"/>
+              <a:buFont typeface="+mj-lt"/>
+              <a:buAutoNum type="arabicPeriod" startAt="4"/>
+            </a:pPr>
+            <a:r>
+              <a:rPr lang="en-US" sz="1350" dirty="0">
+                <a:solidFill>
+                  <a:srgbClr val="504C49"/>
+                </a:solidFill>
+                <a:latin typeface="Source Serif 4" pitchFamily="34" charset="0"/>
+                <a:ea typeface="Source Serif 4" pitchFamily="34" charset="-122"/>
+                <a:cs typeface="Source Serif 4" pitchFamily="34" charset="-120"/>
+              </a:rPr>
+              <a:t>             </a:t>
+            </a:r>
+            <a:r>
+              <a:rPr lang="en-US" sz="1350" b="1" dirty="0">
+                <a:solidFill>
+                  <a:srgbClr val="504C49"/>
+                </a:solidFill>
+                <a:latin typeface="Source Serif 4 Bold" pitchFamily="34" charset="0"/>
+                <a:ea typeface="Source Serif 4 Bold" pitchFamily="34" charset="-122"/>
+                <a:cs typeface="Source Serif 4 Bold" pitchFamily="34" charset="-120"/>
+              </a:rPr>
+              <a:t>Hafta 8:</a:t>
+            </a:r>
+            <a:r>
+              <a:rPr lang="en-US" sz="1350" dirty="0">
+                <a:solidFill>
+                  <a:srgbClr val="504C49"/>
+                </a:solidFill>
+                <a:latin typeface="Source Serif 4" pitchFamily="34" charset="0"/>
+                <a:ea typeface="Source Serif 4" pitchFamily="34" charset="-122"/>
+                <a:cs typeface="Source Serif 4" pitchFamily="34" charset="-120"/>
+              </a:rPr>
+              <a:t> VİZE           </a:t>
+            </a:r>
+            <a:endParaRPr lang="en-US" sz="1350" dirty="0"/>
+          </a:p>
+          <a:p>
+            <a:pPr marL="274320" indent="-274320" algn="l">
+              <a:lnSpc>
+                <a:spcPct val="129000"/>
+              </a:lnSpc>
+              <a:buSzPct val="100000"/>
+              <a:buFont typeface="+mj-lt"/>
+              <a:buAutoNum type="arabicPeriod" startAt="5"/>
+            </a:pPr>
+            <a:r>
+              <a:rPr lang="en-US" sz="1350" dirty="0">
+                <a:solidFill>
+                  <a:srgbClr val="504C49"/>
+                </a:solidFill>
+                <a:latin typeface="Source Serif 4" pitchFamily="34" charset="0"/>
+                <a:ea typeface="Source Serif 4" pitchFamily="34" charset="-122"/>
+                <a:cs typeface="Source Serif 4" pitchFamily="34" charset="-120"/>
+              </a:rPr>
+              <a:t>             </a:t>
+            </a:r>
+            <a:r>
+              <a:rPr lang="en-US" sz="1350" b="1" dirty="0">
+                <a:solidFill>
+                  <a:srgbClr val="504C49"/>
+                </a:solidFill>
+                <a:latin typeface="Source Serif 4 Bold" pitchFamily="34" charset="0"/>
+                <a:ea typeface="Source Serif 4 Bold" pitchFamily="34" charset="-122"/>
+                <a:cs typeface="Source Serif 4 Bold" pitchFamily="34" charset="-120"/>
+              </a:rPr>
+              <a:t>Hafta 9:</a:t>
+            </a:r>
+            <a:r>
+              <a:rPr lang="en-US" sz="1350" dirty="0">
+                <a:solidFill>
+                  <a:srgbClr val="504C49"/>
+                </a:solidFill>
+                <a:latin typeface="Source Serif 4" pitchFamily="34" charset="0"/>
+                <a:ea typeface="Source Serif 4" pitchFamily="34" charset="-122"/>
+                <a:cs typeface="Source Serif 4" pitchFamily="34" charset="-120"/>
+              </a:rPr>
+              <a:t> Model Değerlendirme ve ROI           </a:t>
+            </a:r>
+            <a:endParaRPr lang="en-US" sz="1350" dirty="0"/>
+          </a:p>
+          <a:p>
+            <a:pPr marL="274320" indent="-274320" algn="l">
+              <a:lnSpc>
+                <a:spcPct val="129000"/>
+              </a:lnSpc>
+              <a:buSzPct val="100000"/>
+              <a:buFont typeface="+mj-lt"/>
+              <a:buAutoNum type="arabicPeriod" startAt="6"/>
+            </a:pPr>
+            <a:r>
+              <a:rPr lang="en-US" sz="1350" dirty="0">
+                <a:solidFill>
+                  <a:srgbClr val="504C49"/>
+                </a:solidFill>
+                <a:latin typeface="Source Serif 4" pitchFamily="34" charset="0"/>
+                <a:ea typeface="Source Serif 4" pitchFamily="34" charset="-122"/>
+                <a:cs typeface="Source Serif 4" pitchFamily="34" charset="-120"/>
+              </a:rPr>
+              <a:t>             </a:t>
+            </a:r>
+            <a:r>
+              <a:rPr lang="en-US" sz="1350" b="1" dirty="0">
+                <a:solidFill>
+                  <a:srgbClr val="504C49"/>
+                </a:solidFill>
+                <a:latin typeface="Source Serif 4 Bold" pitchFamily="34" charset="0"/>
+                <a:ea typeface="Source Serif 4 Bold" pitchFamily="34" charset="-122"/>
+                <a:cs typeface="Source Serif 4 Bold" pitchFamily="34" charset="-120"/>
+              </a:rPr>
+              <a:t>Hafta 10:</a:t>
+            </a:r>
+            <a:r>
+              <a:rPr lang="en-US" sz="1350" dirty="0">
+                <a:solidFill>
+                  <a:srgbClr val="504C49"/>
+                </a:solidFill>
+                <a:latin typeface="Source Serif 4" pitchFamily="34" charset="0"/>
+                <a:ea typeface="Source Serif 4" pitchFamily="34" charset="-122"/>
+                <a:cs typeface="Source Serif 4" pitchFamily="34" charset="-120"/>
+              </a:rPr>
+              <a:t> Orchestration (Airflow/Prefect)           </a:t>
+            </a:r>
+            <a:endParaRPr lang="en-US" sz="1350" dirty="0"/>
+          </a:p>
+          <a:p>
+            <a:pPr marL="274320" indent="-274320" algn="l">
+              <a:lnSpc>
+                <a:spcPct val="129000"/>
+              </a:lnSpc>
+              <a:buSzPct val="100000"/>
+              <a:buFont typeface="+mj-lt"/>
+              <a:buAutoNum type="arabicPeriod" startAt="7"/>
+            </a:pPr>
+            <a:r>
+              <a:rPr lang="en-US" sz="1350" dirty="0">
+                <a:solidFill>
+                  <a:srgbClr val="504C49"/>
+                </a:solidFill>
+                <a:latin typeface="Source Serif 4" pitchFamily="34" charset="0"/>
+                <a:ea typeface="Source Serif 4" pitchFamily="34" charset="-122"/>
+                <a:cs typeface="Source Serif 4" pitchFamily="34" charset="-120"/>
+              </a:rPr>
+              <a:t>             </a:t>
+            </a:r>
+            <a:r>
+              <a:rPr lang="en-US" sz="1350" b="1" dirty="0">
+                <a:solidFill>
+                  <a:srgbClr val="504C49"/>
+                </a:solidFill>
+                <a:latin typeface="Source Serif 4 Bold" pitchFamily="34" charset="0"/>
+                <a:ea typeface="Source Serif 4 Bold" pitchFamily="34" charset="-122"/>
+                <a:cs typeface="Source Serif 4 Bold" pitchFamily="34" charset="-120"/>
+              </a:rPr>
+              <a:t>Hafta 11:</a:t>
+            </a:r>
+            <a:r>
+              <a:rPr lang="en-US" sz="1350" dirty="0">
+                <a:solidFill>
+                  <a:srgbClr val="504C49"/>
+                </a:solidFill>
+                <a:latin typeface="Source Serif 4" pitchFamily="34" charset="0"/>
+                <a:ea typeface="Source Serif 4" pitchFamily="34" charset="-122"/>
+                <a:cs typeface="Source Serif 4" pitchFamily="34" charset="-120"/>
+              </a:rPr>
+              <a:t> FastAPI ve Docker ile Deployment           </a:t>
+            </a:r>
+            <a:endParaRPr lang="en-US" sz="1350" dirty="0"/>
+          </a:p>
+          <a:p>
+            <a:pPr marL="274320" indent="-274320" algn="l">
+              <a:lnSpc>
+                <a:spcPct val="129000"/>
+              </a:lnSpc>
+              <a:buSzPct val="100000"/>
+              <a:buFont typeface="+mj-lt"/>
+              <a:buAutoNum type="arabicPeriod" startAt="8"/>
+            </a:pPr>
+            <a:r>
+              <a:rPr lang="en-US" sz="1350" dirty="0">
+                <a:solidFill>
+                  <a:srgbClr val="504C49"/>
+                </a:solidFill>
+                <a:latin typeface="Source Serif 4" pitchFamily="34" charset="0"/>
+                <a:ea typeface="Source Serif 4" pitchFamily="34" charset="-122"/>
+                <a:cs typeface="Source Serif 4" pitchFamily="34" charset="-120"/>
+              </a:rPr>
+              <a:t>             </a:t>
+            </a:r>
+            <a:r>
+              <a:rPr lang="en-US" sz="1350" b="1" dirty="0">
+                <a:solidFill>
+                  <a:srgbClr val="504C49"/>
+                </a:solidFill>
+                <a:latin typeface="Source Serif 4 Bold" pitchFamily="34" charset="0"/>
+                <a:ea typeface="Source Serif 4 Bold" pitchFamily="34" charset="-122"/>
+                <a:cs typeface="Source Serif 4 Bold" pitchFamily="34" charset="-120"/>
+              </a:rPr>
+              <a:t>Hafta 12:</a:t>
+            </a:r>
+            <a:r>
+              <a:rPr lang="en-US" sz="1350" dirty="0">
+                <a:solidFill>
+                  <a:srgbClr val="504C49"/>
+                </a:solidFill>
+                <a:latin typeface="Source Serif 4" pitchFamily="34" charset="0"/>
+                <a:ea typeface="Source Serif 4" pitchFamily="34" charset="-122"/>
+                <a:cs typeface="Source Serif 4" pitchFamily="34" charset="-120"/>
+              </a:rPr>
+              <a:t> Model Drift ve Monitoring (PSI/K-S)           </a:t>
+            </a:r>
+            <a:endParaRPr lang="en-US" sz="1350" dirty="0"/>
+          </a:p>
+          <a:p>
+            <a:pPr marL="274320" indent="-274320" algn="l">
+              <a:lnSpc>
+                <a:spcPct val="129000"/>
+              </a:lnSpc>
+              <a:buSzPct val="100000"/>
+              <a:buFont typeface="+mj-lt"/>
+              <a:buAutoNum type="arabicPeriod" startAt="9"/>
+            </a:pPr>
+            <a:r>
+              <a:rPr lang="en-US" sz="1350" dirty="0">
+                <a:solidFill>
+                  <a:srgbClr val="504C49"/>
+                </a:solidFill>
+                <a:latin typeface="Source Serif 4" pitchFamily="34" charset="0"/>
+                <a:ea typeface="Source Serif 4" pitchFamily="34" charset="-122"/>
+                <a:cs typeface="Source Serif 4" pitchFamily="34" charset="-120"/>
+              </a:rPr>
+              <a:t>             </a:t>
+            </a:r>
+            <a:r>
+              <a:rPr lang="en-US" sz="1350" b="1" dirty="0">
+                <a:solidFill>
+                  <a:srgbClr val="504C49"/>
+                </a:solidFill>
+                <a:latin typeface="Source Serif 4 Bold" pitchFamily="34" charset="0"/>
+                <a:ea typeface="Source Serif 4 Bold" pitchFamily="34" charset="-122"/>
+                <a:cs typeface="Source Serif 4 Bold" pitchFamily="34" charset="-120"/>
+              </a:rPr>
+              <a:t>Hafta 13:</a:t>
+            </a:r>
+            <a:r>
+              <a:rPr lang="en-US" sz="1350" dirty="0">
+                <a:solidFill>
+                  <a:srgbClr val="504C49"/>
+                </a:solidFill>
+                <a:latin typeface="Source Serif 4" pitchFamily="34" charset="0"/>
+                <a:ea typeface="Source Serif 4" pitchFamily="34" charset="-122"/>
+                <a:cs typeface="Source Serif 4" pitchFamily="34" charset="-120"/>
+              </a:rPr>
+              <a:t> LLM, RAG ve Autoresearch (AI Agents)           </a:t>
+            </a:r>
+            <a:endParaRPr lang="en-US" sz="1350" dirty="0"/>
+          </a:p>
+          <a:p>
+            <a:pPr marL="274320" indent="-274320" algn="l">
+              <a:lnSpc>
+                <a:spcPct val="129000"/>
+              </a:lnSpc>
+              <a:buSzPct val="100000"/>
+              <a:buFont typeface="+mj-lt"/>
+              <a:buAutoNum type="arabicPeriod" startAt="10"/>
+            </a:pPr>
+            <a:r>
+              <a:rPr lang="en-US" sz="1350" dirty="0">
+                <a:solidFill>
+                  <a:srgbClr val="504C49"/>
+                </a:solidFill>
+                <a:latin typeface="Source Serif 4" pitchFamily="34" charset="0"/>
+                <a:ea typeface="Source Serif 4" pitchFamily="34" charset="-122"/>
+                <a:cs typeface="Source Serif 4" pitchFamily="34" charset="-120"/>
+              </a:rPr>
+              <a:t>             </a:t>
+            </a:r>
+            <a:r>
+              <a:rPr lang="en-US" sz="1350" b="1" dirty="0">
+                <a:solidFill>
+                  <a:srgbClr val="504C49"/>
+                </a:solidFill>
+                <a:latin typeface="Source Serif 4 Bold" pitchFamily="34" charset="0"/>
+                <a:ea typeface="Source Serif 4 Bold" pitchFamily="34" charset="-122"/>
+                <a:cs typeface="Source Serif 4 Bold" pitchFamily="34" charset="-120"/>
+              </a:rPr>
+              <a:t>Hafta 14:</a:t>
+            </a:r>
+            <a:r>
+              <a:rPr lang="en-US" sz="1350" dirty="0">
+                <a:solidFill>
+                  <a:srgbClr val="504C49"/>
+                </a:solidFill>
+                <a:latin typeface="Source Serif 4" pitchFamily="34" charset="0"/>
+                <a:ea typeface="Source Serif 4" pitchFamily="34" charset="-122"/>
+                <a:cs typeface="Source Serif 4" pitchFamily="34" charset="-120"/>
+              </a:rPr>
+              <a:t> Proje Sunumları ve Code Review           </a:t>
+            </a:r>
+            <a:endParaRPr lang="en-US" sz="1350" dirty="0"/>
+          </a:p>
+          <a:p>
+            <a:pPr marL="274320" indent="-274320" algn="l">
+              <a:lnSpc>
+                <a:spcPct val="129000"/>
+              </a:lnSpc>
+              <a:buSzPct val="100000"/>
+              <a:buFont typeface="+mj-lt"/>
+              <a:buAutoNum type="arabicPeriod" startAt="11"/>
+            </a:pPr>
+            <a:r>
+              <a:rPr lang="en-US" sz="1350" dirty="0">
+                <a:solidFill>
+                  <a:srgbClr val="504C49"/>
+                </a:solidFill>
+                <a:latin typeface="Source Serif 4" pitchFamily="34" charset="0"/>
+                <a:ea typeface="Source Serif 4" pitchFamily="34" charset="-122"/>
+                <a:cs typeface="Source Serif 4" pitchFamily="34" charset="-120"/>
+              </a:rPr>
+              <a:t>             </a:t>
+            </a:r>
+            <a:r>
+              <a:rPr lang="en-US" sz="1350" b="1" dirty="0">
+                <a:solidFill>
+                  <a:srgbClr val="504C49"/>
+                </a:solidFill>
+                <a:latin typeface="Source Serif 4 Bold" pitchFamily="34" charset="0"/>
+                <a:ea typeface="Source Serif 4 Bold" pitchFamily="34" charset="-122"/>
+                <a:cs typeface="Source Serif 4 Bold" pitchFamily="34" charset="-120"/>
+              </a:rPr>
+              <a:t>Hafta 15:</a:t>
+            </a:r>
+            <a:r>
+              <a:rPr lang="en-US" sz="1350" dirty="0">
+                <a:solidFill>
+                  <a:srgbClr val="504C49"/>
+                </a:solidFill>
+                <a:latin typeface="Source Serif 4" pitchFamily="34" charset="0"/>
+                <a:ea typeface="Source Serif 4" pitchFamily="34" charset="-122"/>
+                <a:cs typeface="Source Serif 4" pitchFamily="34" charset="-120"/>
+              </a:rPr>
+              <a:t> FİNAL           </a:t>
+            </a:r>
+            <a:endParaRPr lang="en-US" sz="1350" dirty="0"/>
+          </a:p>
+        </p:txBody>
+      </p:sp>
+      <p:pic>
+        <p:nvPicPr>
+          <p:cNvPr id="8" name="Resim 7">
+            <a:extLst>
+              <a:ext uri="{FF2B5EF4-FFF2-40B4-BE49-F238E27FC236}">
+                <a16:creationId xmlns:a16="http://schemas.microsoft.com/office/drawing/2014/main" id="{3930611E-10F8-96A2-7BEF-8ABA2162A2EE}"/>
+              </a:ext>
+            </a:extLst>
+          </p:cNvPr>
+          <p:cNvPicPr>
+            <a:picLocks noChangeAspect="1"/>
+          </p:cNvPicPr>
+          <p:nvPr/>
+        </p:nvPicPr>
+        <p:blipFill>
+          <a:blip r:embed="rId3"/>
+          <a:stretch>
+            <a:fillRect/>
+          </a:stretch>
+        </p:blipFill>
+        <p:spPr>
+          <a:xfrm>
+            <a:off x="10639425" y="6134100"/>
+            <a:ext cx="1552575" cy="723900"/>
+          </a:xfrm>
+          <a:prstGeom prst="rect">
+            <a:avLst/>
+          </a:prstGeom>
+        </p:spPr>
+      </p:pic>
+    </p:spTree>
+  </p:cSld>
+  <p:clrMapOvr>
+    <a:masterClrMapping/>
+  </p:clrMapOvr>
+</p:sld>
+</file>
+
+<file path=ppt/slides/slide5.xml><?xml version="1.0" encoding="utf-8"?>
+<p:sld xmlns:a="http://schemas.openxmlformats.org/drawingml/2006/main" xmlns:r="http://schemas.openxmlformats.org/officeDocument/2006/relationships" xmlns:p="http://schemas.openxmlformats.org/presentationml/2006/main">
   <p:cSld name="Slide 4">
     <p:spTree>
       <p:nvGrpSpPr>
@@ -8216,897 +9107,6 @@
         </p:nvPicPr>
         <p:blipFill>
           <a:blip r:embed="rId8"/>
-          <a:stretch>
-            <a:fillRect/>
-          </a:stretch>
-        </p:blipFill>
-        <p:spPr>
-          <a:xfrm>
-            <a:off x="10639425" y="6134100"/>
-            <a:ext cx="1552575" cy="723900"/>
-          </a:xfrm>
-          <a:prstGeom prst="rect">
-            <a:avLst/>
-          </a:prstGeom>
-        </p:spPr>
-      </p:pic>
-    </p:spTree>
-  </p:cSld>
-  <p:clrMapOvr>
-    <a:masterClrMapping/>
-  </p:clrMapOvr>
-</p:sld>
-</file>
-
-<file path=ppt/slides/slide5.xml><?xml version="1.0" encoding="utf-8"?>
-<p:sld xmlns:a="http://schemas.openxmlformats.org/drawingml/2006/main" xmlns:r="http://schemas.openxmlformats.org/officeDocument/2006/relationships" xmlns:p="http://schemas.openxmlformats.org/presentationml/2006/main">
-  <p:cSld name="Slide 5">
-    <p:spTree>
-      <p:nvGrpSpPr>
-        <p:cNvPr id="1" name=""/>
-        <p:cNvGrpSpPr/>
-        <p:nvPr/>
-      </p:nvGrpSpPr>
-      <p:grpSpPr>
-        <a:xfrm>
-          <a:off x="0" y="0"/>
-          <a:ext cx="0" cy="0"/>
-          <a:chOff x="0" y="0"/>
-          <a:chExt cx="0" cy="0"/>
-        </a:xfrm>
-      </p:grpSpPr>
-      <p:sp>
-        <p:nvSpPr>
-          <p:cNvPr id="2" name="Text 0"/>
-          <p:cNvSpPr/>
-          <p:nvPr/>
-        </p:nvSpPr>
-        <p:spPr>
-          <a:xfrm>
-            <a:off x="661475" y="684212"/>
-            <a:ext cx="10868745" cy="553740"/>
-          </a:xfrm>
-          <a:prstGeom prst="rect">
-            <a:avLst/>
-          </a:prstGeom>
-          <a:noFill/>
-          <a:ln/>
-        </p:spPr>
-        <p:txBody>
-          <a:bodyPr wrap="none" lIns="0" tIns="0" rIns="0" bIns="0" rtlCol="0" anchor="t"/>
-          <a:lstStyle/>
-          <a:p>
-            <a:pPr marL="0" indent="0" algn="l">
-              <a:lnSpc>
-                <a:spcPct val="104000"/>
-              </a:lnSpc>
-              <a:buNone/>
-            </a:pPr>
-            <a:r>
-              <a:rPr lang="en-US" sz="3450" dirty="0">
-                <a:solidFill>
-                  <a:srgbClr val="201B18"/>
-                </a:solidFill>
-                <a:latin typeface="Platypi Medium" pitchFamily="34" charset="0"/>
-                <a:ea typeface="Platypi Medium" pitchFamily="34" charset="-122"/>
-                <a:cs typeface="Platypi Medium" pitchFamily="34" charset="-120"/>
-              </a:rPr>
-              <a:t>Haftalık Ders Planı: Detaylı Yol Haritası</a:t>
-            </a:r>
-            <a:endParaRPr lang="en-US" sz="3450" dirty="0"/>
-          </a:p>
-        </p:txBody>
-      </p:sp>
-      <p:sp>
-        <p:nvSpPr>
-          <p:cNvPr id="3" name="Text 1"/>
-          <p:cNvSpPr/>
-          <p:nvPr/>
-        </p:nvSpPr>
-        <p:spPr>
-          <a:xfrm>
-            <a:off x="661475" y="1653183"/>
-            <a:ext cx="5218280" cy="276920"/>
-          </a:xfrm>
-          <a:prstGeom prst="rect">
-            <a:avLst/>
-          </a:prstGeom>
-          <a:noFill/>
-          <a:ln/>
-        </p:spPr>
-        <p:txBody>
-          <a:bodyPr wrap="none" lIns="0" tIns="0" rIns="0" bIns="0" rtlCol="0" anchor="t"/>
-          <a:lstStyle/>
-          <a:p>
-            <a:pPr marL="0" indent="0" algn="l">
-              <a:lnSpc>
-                <a:spcPct val="104000"/>
-              </a:lnSpc>
-              <a:buNone/>
-            </a:pPr>
-            <a:r>
-              <a:rPr lang="en-US" sz="1700" dirty="0">
-                <a:solidFill>
-                  <a:srgbClr val="201B18"/>
-                </a:solidFill>
-                <a:latin typeface="Platypi Medium" pitchFamily="34" charset="0"/>
-                <a:ea typeface="Platypi Medium" pitchFamily="34" charset="-122"/>
-                <a:cs typeface="Platypi Medium" pitchFamily="34" charset="-120"/>
-              </a:rPr>
-              <a:t>Aşama 1: Temel Geliştirme (1-4 Haftalar)</a:t>
-            </a:r>
-            <a:endParaRPr lang="en-US" sz="1700" dirty="0"/>
-          </a:p>
-        </p:txBody>
-      </p:sp>
-      <p:sp>
-        <p:nvSpPr>
-          <p:cNvPr id="4" name="Text 2"/>
-          <p:cNvSpPr/>
-          <p:nvPr/>
-        </p:nvSpPr>
-        <p:spPr>
-          <a:xfrm>
-            <a:off x="661475" y="2096195"/>
-            <a:ext cx="5218280" cy="4019352"/>
-          </a:xfrm>
-          <a:prstGeom prst="rect">
-            <a:avLst/>
-          </a:prstGeom>
-          <a:noFill/>
-          <a:ln/>
-        </p:spPr>
-        <p:txBody>
-          <a:bodyPr wrap="square" lIns="0" tIns="0" rIns="0" bIns="0" rtlCol="0" anchor="t">
-            <a:normAutofit/>
-          </a:bodyPr>
-          <a:lstStyle/>
-          <a:p>
-            <a:pPr marL="274320" indent="-274320" algn="l">
-              <a:lnSpc>
-                <a:spcPct val="129000"/>
-              </a:lnSpc>
-              <a:buSzPct val="100000"/>
-              <a:buFont typeface="+mj-lt"/>
-              <a:buAutoNum type="arabicPeriod"/>
-            </a:pPr>
-            <a:r>
-              <a:rPr lang="en-US" sz="1350" dirty="0">
-                <a:solidFill>
-                  <a:srgbClr val="504C49"/>
-                </a:solidFill>
-                <a:latin typeface="Source Serif 4" pitchFamily="34" charset="0"/>
-                <a:ea typeface="Source Serif 4" pitchFamily="34" charset="-122"/>
-                <a:cs typeface="Source Serif 4" pitchFamily="34" charset="-120"/>
-              </a:rPr>
-              <a:t>             </a:t>
-            </a:r>
-            <a:r>
-              <a:rPr lang="en-US" sz="1350" b="1" dirty="0">
-                <a:solidFill>
-                  <a:srgbClr val="504C49"/>
-                </a:solidFill>
-                <a:latin typeface="Source Serif 4 Bold" pitchFamily="34" charset="0"/>
-                <a:ea typeface="Source Serif 4 Bold" pitchFamily="34" charset="-122"/>
-                <a:cs typeface="Source Serif 4 Bold" pitchFamily="34" charset="-120"/>
-              </a:rPr>
-              <a:t>Hafta 1 (Giriş ve ML Yaşam Döngüsü):</a:t>
-            </a:r>
-            <a:r>
-              <a:rPr lang="en-US" sz="1350" dirty="0">
-                <a:solidFill>
-                  <a:srgbClr val="504C49"/>
-                </a:solidFill>
-                <a:latin typeface="Source Serif 4" pitchFamily="34" charset="0"/>
-                <a:ea typeface="Source Serif 4" pitchFamily="34" charset="-122"/>
-                <a:cs typeface="Source Serif 4" pitchFamily="34" charset="-120"/>
-              </a:rPr>
-              <a:t> SDLC vs MLOps, Agile Veri Bilimi, Notebook'tan Production'a geçiş, modüler .py ve cookiecutter proje mimarisi kurulumu.           </a:t>
-            </a:r>
-            <a:endParaRPr lang="en-US" sz="1350" dirty="0"/>
-          </a:p>
-          <a:p>
-            <a:pPr marL="274320" indent="-274320" algn="l">
-              <a:lnSpc>
-                <a:spcPct val="129000"/>
-              </a:lnSpc>
-              <a:buSzPct val="100000"/>
-              <a:buFont typeface="+mj-lt"/>
-              <a:buAutoNum type="arabicPeriod" startAt="2"/>
-            </a:pPr>
-            <a:r>
-              <a:rPr lang="en-US" sz="1350" dirty="0">
-                <a:solidFill>
-                  <a:srgbClr val="504C49"/>
-                </a:solidFill>
-                <a:latin typeface="Source Serif 4" pitchFamily="34" charset="0"/>
-                <a:ea typeface="Source Serif 4" pitchFamily="34" charset="-122"/>
-                <a:cs typeface="Source Serif 4" pitchFamily="34" charset="-120"/>
-              </a:rPr>
-              <a:t>             </a:t>
-            </a:r>
-            <a:r>
-              <a:rPr lang="en-US" sz="1350" b="1" dirty="0">
-                <a:solidFill>
-                  <a:srgbClr val="504C49"/>
-                </a:solidFill>
-                <a:latin typeface="Source Serif 4 Bold" pitchFamily="34" charset="0"/>
-                <a:ea typeface="Source Serif 4 Bold" pitchFamily="34" charset="-122"/>
-                <a:cs typeface="Source Serif 4 Bold" pitchFamily="34" charset="-120"/>
-              </a:rPr>
-              <a:t>Hafta 2 (Veri Mühendisliği ve Feature Store):</a:t>
-            </a:r>
-            <a:r>
-              <a:rPr lang="en-US" sz="1350" dirty="0">
-                <a:solidFill>
-                  <a:srgbClr val="504C49"/>
-                </a:solidFill>
-                <a:latin typeface="Source Serif 4" pitchFamily="34" charset="0"/>
-                <a:ea typeface="Source Serif 4" pitchFamily="34" charset="-122"/>
-                <a:cs typeface="Source Serif 4" pitchFamily="34" charset="-120"/>
-              </a:rPr>
-              <a:t> ETL/ELT süreçleri, Feature Store (Online/Offline) ve Train-Serve Skew engelleme.           </a:t>
-            </a:r>
-            <a:endParaRPr lang="en-US" sz="1350" dirty="0"/>
-          </a:p>
-          <a:p>
-            <a:pPr marL="274320" indent="-274320" algn="l">
-              <a:lnSpc>
-                <a:spcPct val="129000"/>
-              </a:lnSpc>
-              <a:buSzPct val="100000"/>
-              <a:buFont typeface="+mj-lt"/>
-              <a:buAutoNum type="arabicPeriod" startAt="3"/>
-            </a:pPr>
-            <a:r>
-              <a:rPr lang="en-US" sz="1350" dirty="0">
-                <a:solidFill>
-                  <a:srgbClr val="504C49"/>
-                </a:solidFill>
-                <a:latin typeface="Source Serif 4" pitchFamily="34" charset="0"/>
-                <a:ea typeface="Source Serif 4" pitchFamily="34" charset="-122"/>
-                <a:cs typeface="Source Serif 4" pitchFamily="34" charset="-120"/>
-              </a:rPr>
-              <a:t>             </a:t>
-            </a:r>
-            <a:r>
-              <a:rPr lang="en-US" sz="1350" b="1" dirty="0">
-                <a:solidFill>
-                  <a:srgbClr val="504C49"/>
-                </a:solidFill>
-                <a:latin typeface="Source Serif 4 Bold" pitchFamily="34" charset="0"/>
-                <a:ea typeface="Source Serif 4 Bold" pitchFamily="34" charset="-122"/>
-                <a:cs typeface="Source Serif 4 Bold" pitchFamily="34" charset="-120"/>
-              </a:rPr>
-              <a:t>Hafta 3 (İleri Seviye Algoritmalar - I):</a:t>
-            </a:r>
-            <a:r>
-              <a:rPr lang="en-US" sz="1350" dirty="0">
-                <a:solidFill>
-                  <a:srgbClr val="504C49"/>
-                </a:solidFill>
-                <a:latin typeface="Source Serif 4" pitchFamily="34" charset="0"/>
-                <a:ea typeface="Source Serif 4" pitchFamily="34" charset="-122"/>
-                <a:cs typeface="Source Serif 4" pitchFamily="34" charset="-120"/>
-              </a:rPr>
-              <a:t> Gradient Boosting (XGBoost vs. LightGBM), Sınıf Dengesizliği, Zaman Serisi Bölmesi (Time-Series Split) ve Optuna ile Bayesian Hiper-parametre Optimizasyonu. </a:t>
-            </a:r>
-            <a:endParaRPr lang="en-US" sz="1350" dirty="0"/>
-          </a:p>
-          <a:p>
-            <a:pPr marL="274320" indent="-274320" algn="l">
-              <a:lnSpc>
-                <a:spcPct val="129000"/>
-              </a:lnSpc>
-              <a:buSzPct val="100000"/>
-              <a:buFont typeface="+mj-lt"/>
-              <a:buAutoNum type="arabicPeriod" startAt="4"/>
-            </a:pPr>
-            <a:r>
-              <a:rPr lang="en-US" sz="1350" dirty="0">
-                <a:solidFill>
-                  <a:srgbClr val="504C49"/>
-                </a:solidFill>
-                <a:latin typeface="Source Serif 4" pitchFamily="34" charset="0"/>
-                <a:ea typeface="Source Serif 4" pitchFamily="34" charset="-122"/>
-                <a:cs typeface="Source Serif 4" pitchFamily="34" charset="-120"/>
-              </a:rPr>
-              <a:t>             </a:t>
-            </a:r>
-            <a:r>
-              <a:rPr lang="en-US" sz="1350" b="1" dirty="0">
-                <a:solidFill>
-                  <a:srgbClr val="504C49"/>
-                </a:solidFill>
-                <a:latin typeface="Source Serif 4 Bold" pitchFamily="34" charset="0"/>
-                <a:ea typeface="Source Serif 4 Bold" pitchFamily="34" charset="-122"/>
-                <a:cs typeface="Source Serif 4 Bold" pitchFamily="34" charset="-120"/>
-              </a:rPr>
-              <a:t>Hafta 4 (İleri Seviye Algoritmalar - II):</a:t>
-            </a:r>
-            <a:r>
-              <a:rPr lang="en-US" sz="1350" dirty="0">
-                <a:solidFill>
-                  <a:srgbClr val="504C49"/>
-                </a:solidFill>
-                <a:latin typeface="Source Serif 4" pitchFamily="34" charset="0"/>
-                <a:ea typeface="Source Serif 4" pitchFamily="34" charset="-122"/>
-                <a:cs typeface="Source Serif 4" pitchFamily="34" charset="-120"/>
-              </a:rPr>
-              <a:t> Yüksek kardinaliteli kategorik veriler, CatBoost (Ordered Boosting), Stacking ve Blending ensemble mimarileri kodlama.           </a:t>
-            </a:r>
-            <a:endParaRPr lang="en-US" sz="1350" dirty="0"/>
-          </a:p>
-        </p:txBody>
-      </p:sp>
-      <p:sp>
-        <p:nvSpPr>
-          <p:cNvPr id="5" name="Text 3"/>
-          <p:cNvSpPr/>
-          <p:nvPr/>
-        </p:nvSpPr>
-        <p:spPr>
-          <a:xfrm>
-            <a:off x="6318290" y="1653183"/>
-            <a:ext cx="5218280" cy="553839"/>
-          </a:xfrm>
-          <a:prstGeom prst="rect">
-            <a:avLst/>
-          </a:prstGeom>
-          <a:noFill/>
-          <a:ln/>
-        </p:spPr>
-        <p:txBody>
-          <a:bodyPr wrap="square" lIns="0" tIns="0" rIns="0" bIns="0" rtlCol="0" anchor="t">
-            <a:normAutofit/>
-          </a:bodyPr>
-          <a:lstStyle/>
-          <a:p>
-            <a:pPr marL="0" indent="0" algn="l">
-              <a:lnSpc>
-                <a:spcPct val="104000"/>
-              </a:lnSpc>
-              <a:buNone/>
-            </a:pPr>
-            <a:r>
-              <a:rPr lang="en-US" sz="1700" dirty="0">
-                <a:solidFill>
-                  <a:srgbClr val="201B18"/>
-                </a:solidFill>
-                <a:latin typeface="Platypi Medium" pitchFamily="34" charset="0"/>
-                <a:ea typeface="Platypi Medium" pitchFamily="34" charset="-122"/>
-                <a:cs typeface="Platypi Medium" pitchFamily="34" charset="-120"/>
-              </a:rPr>
-              <a:t>Aşama 2: MLOps, Deployment ve Operasyon (5-15 Haftalar Taslağı)</a:t>
-            </a:r>
-            <a:endParaRPr lang="en-US" sz="1700" dirty="0"/>
-          </a:p>
-        </p:txBody>
-      </p:sp>
-      <p:sp>
-        <p:nvSpPr>
-          <p:cNvPr id="6" name="Text 4"/>
-          <p:cNvSpPr/>
-          <p:nvPr/>
-        </p:nvSpPr>
-        <p:spPr>
-          <a:xfrm>
-            <a:off x="6318290" y="2373114"/>
-            <a:ext cx="5218280" cy="3602434"/>
-          </a:xfrm>
-          <a:prstGeom prst="rect">
-            <a:avLst/>
-          </a:prstGeom>
-          <a:noFill/>
-          <a:ln/>
-        </p:spPr>
-        <p:txBody>
-          <a:bodyPr wrap="square" lIns="0" tIns="0" rIns="0" bIns="0" rtlCol="0" anchor="t">
-            <a:normAutofit/>
-          </a:bodyPr>
-          <a:lstStyle/>
-          <a:p>
-            <a:pPr marL="274320" indent="-274320" algn="l">
-              <a:lnSpc>
-                <a:spcPct val="129000"/>
-              </a:lnSpc>
-              <a:buSzPct val="100000"/>
-              <a:buFont typeface="+mj-lt"/>
-              <a:buAutoNum type="arabicPeriod"/>
-            </a:pPr>
-            <a:r>
-              <a:rPr lang="en-US" sz="1350" dirty="0">
-                <a:solidFill>
-                  <a:srgbClr val="504C49"/>
-                </a:solidFill>
-                <a:latin typeface="Source Serif 4" pitchFamily="34" charset="0"/>
-                <a:ea typeface="Source Serif 4" pitchFamily="34" charset="-122"/>
-                <a:cs typeface="Source Serif 4" pitchFamily="34" charset="-120"/>
-              </a:rPr>
-              <a:t>             </a:t>
-            </a:r>
-            <a:r>
-              <a:rPr lang="en-US" sz="1350" b="1" dirty="0">
-                <a:solidFill>
-                  <a:srgbClr val="504C49"/>
-                </a:solidFill>
-                <a:latin typeface="Source Serif 4 Bold" pitchFamily="34" charset="0"/>
-                <a:ea typeface="Source Serif 4 Bold" pitchFamily="34" charset="-122"/>
-                <a:cs typeface="Source Serif 4 Bold" pitchFamily="34" charset="-120"/>
-              </a:rPr>
-              <a:t>Hafta 5:</a:t>
-            </a:r>
-            <a:r>
-              <a:rPr lang="en-US" sz="1350" dirty="0">
-                <a:solidFill>
-                  <a:srgbClr val="504C49"/>
-                </a:solidFill>
-                <a:latin typeface="Source Serif 4" pitchFamily="34" charset="0"/>
-                <a:ea typeface="Source Serif 4" pitchFamily="34" charset="-122"/>
-                <a:cs typeface="Source Serif 4" pitchFamily="34" charset="-120"/>
-              </a:rPr>
-              <a:t> Mimari Tasarım (Batch vs. Real-time)           </a:t>
-            </a:r>
-            <a:endParaRPr lang="en-US" sz="1350" dirty="0"/>
-          </a:p>
-          <a:p>
-            <a:pPr marL="274320" indent="-274320" algn="l">
-              <a:lnSpc>
-                <a:spcPct val="129000"/>
-              </a:lnSpc>
-              <a:buSzPct val="100000"/>
-              <a:buFont typeface="+mj-lt"/>
-              <a:buAutoNum type="arabicPeriod" startAt="2"/>
-            </a:pPr>
-            <a:r>
-              <a:rPr lang="en-US" sz="1350" dirty="0">
-                <a:solidFill>
-                  <a:srgbClr val="504C49"/>
-                </a:solidFill>
-                <a:latin typeface="Source Serif 4" pitchFamily="34" charset="0"/>
-                <a:ea typeface="Source Serif 4" pitchFamily="34" charset="-122"/>
-                <a:cs typeface="Source Serif 4" pitchFamily="34" charset="-120"/>
-              </a:rPr>
-              <a:t>             </a:t>
-            </a:r>
-            <a:r>
-              <a:rPr lang="en-US" sz="1350" b="1" dirty="0">
-                <a:solidFill>
-                  <a:srgbClr val="504C49"/>
-                </a:solidFill>
-                <a:latin typeface="Source Serif 4 Bold" pitchFamily="34" charset="0"/>
-                <a:ea typeface="Source Serif 4 Bold" pitchFamily="34" charset="-122"/>
-                <a:cs typeface="Source Serif 4 Bold" pitchFamily="34" charset="-120"/>
-              </a:rPr>
-              <a:t>Hafta 6:</a:t>
-            </a:r>
-            <a:r>
-              <a:rPr lang="en-US" sz="1350" dirty="0">
-                <a:solidFill>
-                  <a:srgbClr val="504C49"/>
-                </a:solidFill>
-                <a:latin typeface="Source Serif 4" pitchFamily="34" charset="0"/>
-                <a:ea typeface="Source Serif 4" pitchFamily="34" charset="-122"/>
-                <a:cs typeface="Source Serif 4" pitchFamily="34" charset="-120"/>
-              </a:rPr>
-              <a:t> Deney Takibi ve MLflow           </a:t>
-            </a:r>
-            <a:endParaRPr lang="en-US" sz="1350" dirty="0"/>
-          </a:p>
-          <a:p>
-            <a:pPr marL="274320" indent="-274320" algn="l">
-              <a:lnSpc>
-                <a:spcPct val="129000"/>
-              </a:lnSpc>
-              <a:buSzPct val="100000"/>
-              <a:buFont typeface="+mj-lt"/>
-              <a:buAutoNum type="arabicPeriod" startAt="3"/>
-            </a:pPr>
-            <a:r>
-              <a:rPr lang="en-US" sz="1350" dirty="0">
-                <a:solidFill>
-                  <a:srgbClr val="504C49"/>
-                </a:solidFill>
-                <a:latin typeface="Source Serif 4" pitchFamily="34" charset="0"/>
-                <a:ea typeface="Source Serif 4" pitchFamily="34" charset="-122"/>
-                <a:cs typeface="Source Serif 4" pitchFamily="34" charset="-120"/>
-              </a:rPr>
-              <a:t>             </a:t>
-            </a:r>
-            <a:r>
-              <a:rPr lang="en-US" sz="1350" b="1" dirty="0">
-                <a:solidFill>
-                  <a:srgbClr val="504C49"/>
-                </a:solidFill>
-                <a:latin typeface="Source Serif 4 Bold" pitchFamily="34" charset="0"/>
-                <a:ea typeface="Source Serif 4 Bold" pitchFamily="34" charset="-122"/>
-                <a:cs typeface="Source Serif 4 Bold" pitchFamily="34" charset="-120"/>
-              </a:rPr>
-              <a:t>Hafta 7:</a:t>
-            </a:r>
-            <a:r>
-              <a:rPr lang="en-US" sz="1350" dirty="0">
-                <a:solidFill>
-                  <a:srgbClr val="504C49"/>
-                </a:solidFill>
-                <a:latin typeface="Source Serif 4" pitchFamily="34" charset="0"/>
-                <a:ea typeface="Source Serif 4" pitchFamily="34" charset="-122"/>
-                <a:cs typeface="Source Serif 4" pitchFamily="34" charset="-120"/>
-              </a:rPr>
-              <a:t> Sınıflandırma/Regresyon İleri Konular           </a:t>
-            </a:r>
-            <a:endParaRPr lang="en-US" sz="1350" dirty="0"/>
-          </a:p>
-          <a:p>
-            <a:pPr marL="274320" indent="-274320" algn="l">
-              <a:lnSpc>
-                <a:spcPct val="129000"/>
-              </a:lnSpc>
-              <a:buSzPct val="100000"/>
-              <a:buFont typeface="+mj-lt"/>
-              <a:buAutoNum type="arabicPeriod" startAt="4"/>
-            </a:pPr>
-            <a:r>
-              <a:rPr lang="en-US" sz="1350" dirty="0">
-                <a:solidFill>
-                  <a:srgbClr val="504C49"/>
-                </a:solidFill>
-                <a:latin typeface="Source Serif 4" pitchFamily="34" charset="0"/>
-                <a:ea typeface="Source Serif 4" pitchFamily="34" charset="-122"/>
-                <a:cs typeface="Source Serif 4" pitchFamily="34" charset="-120"/>
-              </a:rPr>
-              <a:t>             </a:t>
-            </a:r>
-            <a:r>
-              <a:rPr lang="en-US" sz="1350" b="1" dirty="0">
-                <a:solidFill>
-                  <a:srgbClr val="504C49"/>
-                </a:solidFill>
-                <a:latin typeface="Source Serif 4 Bold" pitchFamily="34" charset="0"/>
-                <a:ea typeface="Source Serif 4 Bold" pitchFamily="34" charset="-122"/>
-                <a:cs typeface="Source Serif 4 Bold" pitchFamily="34" charset="-120"/>
-              </a:rPr>
-              <a:t>Hafta 8:</a:t>
-            </a:r>
-            <a:r>
-              <a:rPr lang="en-US" sz="1350" dirty="0">
-                <a:solidFill>
-                  <a:srgbClr val="504C49"/>
-                </a:solidFill>
-                <a:latin typeface="Source Serif 4" pitchFamily="34" charset="0"/>
-                <a:ea typeface="Source Serif 4" pitchFamily="34" charset="-122"/>
-                <a:cs typeface="Source Serif 4" pitchFamily="34" charset="-120"/>
-              </a:rPr>
-              <a:t> VİZE           </a:t>
-            </a:r>
-            <a:endParaRPr lang="en-US" sz="1350" dirty="0"/>
-          </a:p>
-          <a:p>
-            <a:pPr marL="274320" indent="-274320" algn="l">
-              <a:lnSpc>
-                <a:spcPct val="129000"/>
-              </a:lnSpc>
-              <a:buSzPct val="100000"/>
-              <a:buFont typeface="+mj-lt"/>
-              <a:buAutoNum type="arabicPeriod" startAt="5"/>
-            </a:pPr>
-            <a:r>
-              <a:rPr lang="en-US" sz="1350" dirty="0">
-                <a:solidFill>
-                  <a:srgbClr val="504C49"/>
-                </a:solidFill>
-                <a:latin typeface="Source Serif 4" pitchFamily="34" charset="0"/>
-                <a:ea typeface="Source Serif 4" pitchFamily="34" charset="-122"/>
-                <a:cs typeface="Source Serif 4" pitchFamily="34" charset="-120"/>
-              </a:rPr>
-              <a:t>             </a:t>
-            </a:r>
-            <a:r>
-              <a:rPr lang="en-US" sz="1350" b="1" dirty="0">
-                <a:solidFill>
-                  <a:srgbClr val="504C49"/>
-                </a:solidFill>
-                <a:latin typeface="Source Serif 4 Bold" pitchFamily="34" charset="0"/>
-                <a:ea typeface="Source Serif 4 Bold" pitchFamily="34" charset="-122"/>
-                <a:cs typeface="Source Serif 4 Bold" pitchFamily="34" charset="-120"/>
-              </a:rPr>
-              <a:t>Hafta 9:</a:t>
-            </a:r>
-            <a:r>
-              <a:rPr lang="en-US" sz="1350" dirty="0">
-                <a:solidFill>
-                  <a:srgbClr val="504C49"/>
-                </a:solidFill>
-                <a:latin typeface="Source Serif 4" pitchFamily="34" charset="0"/>
-                <a:ea typeface="Source Serif 4" pitchFamily="34" charset="-122"/>
-                <a:cs typeface="Source Serif 4" pitchFamily="34" charset="-120"/>
-              </a:rPr>
-              <a:t> Model Değerlendirme ve ROI           </a:t>
-            </a:r>
-            <a:endParaRPr lang="en-US" sz="1350" dirty="0"/>
-          </a:p>
-          <a:p>
-            <a:pPr marL="274320" indent="-274320" algn="l">
-              <a:lnSpc>
-                <a:spcPct val="129000"/>
-              </a:lnSpc>
-              <a:buSzPct val="100000"/>
-              <a:buFont typeface="+mj-lt"/>
-              <a:buAutoNum type="arabicPeriod" startAt="6"/>
-            </a:pPr>
-            <a:r>
-              <a:rPr lang="en-US" sz="1350" dirty="0">
-                <a:solidFill>
-                  <a:srgbClr val="504C49"/>
-                </a:solidFill>
-                <a:latin typeface="Source Serif 4" pitchFamily="34" charset="0"/>
-                <a:ea typeface="Source Serif 4" pitchFamily="34" charset="-122"/>
-                <a:cs typeface="Source Serif 4" pitchFamily="34" charset="-120"/>
-              </a:rPr>
-              <a:t>             </a:t>
-            </a:r>
-            <a:r>
-              <a:rPr lang="en-US" sz="1350" b="1" dirty="0">
-                <a:solidFill>
-                  <a:srgbClr val="504C49"/>
-                </a:solidFill>
-                <a:latin typeface="Source Serif 4 Bold" pitchFamily="34" charset="0"/>
-                <a:ea typeface="Source Serif 4 Bold" pitchFamily="34" charset="-122"/>
-                <a:cs typeface="Source Serif 4 Bold" pitchFamily="34" charset="-120"/>
-              </a:rPr>
-              <a:t>Hafta 10:</a:t>
-            </a:r>
-            <a:r>
-              <a:rPr lang="en-US" sz="1350" dirty="0">
-                <a:solidFill>
-                  <a:srgbClr val="504C49"/>
-                </a:solidFill>
-                <a:latin typeface="Source Serif 4" pitchFamily="34" charset="0"/>
-                <a:ea typeface="Source Serif 4" pitchFamily="34" charset="-122"/>
-                <a:cs typeface="Source Serif 4" pitchFamily="34" charset="-120"/>
-              </a:rPr>
-              <a:t> Orchestration (Airflow/Prefect)           </a:t>
-            </a:r>
-            <a:endParaRPr lang="en-US" sz="1350" dirty="0"/>
-          </a:p>
-          <a:p>
-            <a:pPr marL="274320" indent="-274320" algn="l">
-              <a:lnSpc>
-                <a:spcPct val="129000"/>
-              </a:lnSpc>
-              <a:buSzPct val="100000"/>
-              <a:buFont typeface="+mj-lt"/>
-              <a:buAutoNum type="arabicPeriod" startAt="7"/>
-            </a:pPr>
-            <a:r>
-              <a:rPr lang="en-US" sz="1350" dirty="0">
-                <a:solidFill>
-                  <a:srgbClr val="504C49"/>
-                </a:solidFill>
-                <a:latin typeface="Source Serif 4" pitchFamily="34" charset="0"/>
-                <a:ea typeface="Source Serif 4" pitchFamily="34" charset="-122"/>
-                <a:cs typeface="Source Serif 4" pitchFamily="34" charset="-120"/>
-              </a:rPr>
-              <a:t>             </a:t>
-            </a:r>
-            <a:r>
-              <a:rPr lang="en-US" sz="1350" b="1" dirty="0">
-                <a:solidFill>
-                  <a:srgbClr val="504C49"/>
-                </a:solidFill>
-                <a:latin typeface="Source Serif 4 Bold" pitchFamily="34" charset="0"/>
-                <a:ea typeface="Source Serif 4 Bold" pitchFamily="34" charset="-122"/>
-                <a:cs typeface="Source Serif 4 Bold" pitchFamily="34" charset="-120"/>
-              </a:rPr>
-              <a:t>Hafta 11:</a:t>
-            </a:r>
-            <a:r>
-              <a:rPr lang="en-US" sz="1350" dirty="0">
-                <a:solidFill>
-                  <a:srgbClr val="504C49"/>
-                </a:solidFill>
-                <a:latin typeface="Source Serif 4" pitchFamily="34" charset="0"/>
-                <a:ea typeface="Source Serif 4" pitchFamily="34" charset="-122"/>
-                <a:cs typeface="Source Serif 4" pitchFamily="34" charset="-120"/>
-              </a:rPr>
-              <a:t> FastAPI ve Docker ile Deployment           </a:t>
-            </a:r>
-            <a:endParaRPr lang="en-US" sz="1350" dirty="0"/>
-          </a:p>
-          <a:p>
-            <a:pPr marL="274320" indent="-274320" algn="l">
-              <a:lnSpc>
-                <a:spcPct val="129000"/>
-              </a:lnSpc>
-              <a:buSzPct val="100000"/>
-              <a:buFont typeface="+mj-lt"/>
-              <a:buAutoNum type="arabicPeriod" startAt="8"/>
-            </a:pPr>
-            <a:r>
-              <a:rPr lang="en-US" sz="1350" dirty="0">
-                <a:solidFill>
-                  <a:srgbClr val="504C49"/>
-                </a:solidFill>
-                <a:latin typeface="Source Serif 4" pitchFamily="34" charset="0"/>
-                <a:ea typeface="Source Serif 4" pitchFamily="34" charset="-122"/>
-                <a:cs typeface="Source Serif 4" pitchFamily="34" charset="-120"/>
-              </a:rPr>
-              <a:t>             </a:t>
-            </a:r>
-            <a:r>
-              <a:rPr lang="en-US" sz="1350" b="1" dirty="0">
-                <a:solidFill>
-                  <a:srgbClr val="504C49"/>
-                </a:solidFill>
-                <a:latin typeface="Source Serif 4 Bold" pitchFamily="34" charset="0"/>
-                <a:ea typeface="Source Serif 4 Bold" pitchFamily="34" charset="-122"/>
-                <a:cs typeface="Source Serif 4 Bold" pitchFamily="34" charset="-120"/>
-              </a:rPr>
-              <a:t>Hafta 12:</a:t>
-            </a:r>
-            <a:r>
-              <a:rPr lang="en-US" sz="1350" dirty="0">
-                <a:solidFill>
-                  <a:srgbClr val="504C49"/>
-                </a:solidFill>
-                <a:latin typeface="Source Serif 4" pitchFamily="34" charset="0"/>
-                <a:ea typeface="Source Serif 4" pitchFamily="34" charset="-122"/>
-                <a:cs typeface="Source Serif 4" pitchFamily="34" charset="-120"/>
-              </a:rPr>
-              <a:t> Model Drift ve Monitoring (PSI/K-S)           </a:t>
-            </a:r>
-            <a:endParaRPr lang="en-US" sz="1350" dirty="0"/>
-          </a:p>
-          <a:p>
-            <a:pPr marL="274320" indent="-274320" algn="l">
-              <a:lnSpc>
-                <a:spcPct val="129000"/>
-              </a:lnSpc>
-              <a:buSzPct val="100000"/>
-              <a:buFont typeface="+mj-lt"/>
-              <a:buAutoNum type="arabicPeriod" startAt="9"/>
-            </a:pPr>
-            <a:r>
-              <a:rPr lang="en-US" sz="1350" dirty="0">
-                <a:solidFill>
-                  <a:srgbClr val="504C49"/>
-                </a:solidFill>
-                <a:latin typeface="Source Serif 4" pitchFamily="34" charset="0"/>
-                <a:ea typeface="Source Serif 4" pitchFamily="34" charset="-122"/>
-                <a:cs typeface="Source Serif 4" pitchFamily="34" charset="-120"/>
-              </a:rPr>
-              <a:t>             </a:t>
-            </a:r>
-            <a:r>
-              <a:rPr lang="en-US" sz="1350" b="1" dirty="0">
-                <a:solidFill>
-                  <a:srgbClr val="504C49"/>
-                </a:solidFill>
-                <a:latin typeface="Source Serif 4 Bold" pitchFamily="34" charset="0"/>
-                <a:ea typeface="Source Serif 4 Bold" pitchFamily="34" charset="-122"/>
-                <a:cs typeface="Source Serif 4 Bold" pitchFamily="34" charset="-120"/>
-              </a:rPr>
-              <a:t>Hafta 13:</a:t>
-            </a:r>
-            <a:r>
-              <a:rPr lang="en-US" sz="1350" dirty="0">
-                <a:solidFill>
-                  <a:srgbClr val="504C49"/>
-                </a:solidFill>
-                <a:latin typeface="Source Serif 4" pitchFamily="34" charset="0"/>
-                <a:ea typeface="Source Serif 4" pitchFamily="34" charset="-122"/>
-                <a:cs typeface="Source Serif 4" pitchFamily="34" charset="-120"/>
-              </a:rPr>
-              <a:t> LLM, RAG ve Autoresearch (AI Agents)           </a:t>
-            </a:r>
-            <a:endParaRPr lang="en-US" sz="1350" dirty="0"/>
-          </a:p>
-          <a:p>
-            <a:pPr marL="274320" indent="-274320" algn="l">
-              <a:lnSpc>
-                <a:spcPct val="129000"/>
-              </a:lnSpc>
-              <a:buSzPct val="100000"/>
-              <a:buFont typeface="+mj-lt"/>
-              <a:buAutoNum type="arabicPeriod" startAt="10"/>
-            </a:pPr>
-            <a:r>
-              <a:rPr lang="en-US" sz="1350" dirty="0">
-                <a:solidFill>
-                  <a:srgbClr val="504C49"/>
-                </a:solidFill>
-                <a:latin typeface="Source Serif 4" pitchFamily="34" charset="0"/>
-                <a:ea typeface="Source Serif 4" pitchFamily="34" charset="-122"/>
-                <a:cs typeface="Source Serif 4" pitchFamily="34" charset="-120"/>
-              </a:rPr>
-              <a:t>             </a:t>
-            </a:r>
-            <a:r>
-              <a:rPr lang="en-US" sz="1350" b="1" dirty="0">
-                <a:solidFill>
-                  <a:srgbClr val="504C49"/>
-                </a:solidFill>
-                <a:latin typeface="Source Serif 4 Bold" pitchFamily="34" charset="0"/>
-                <a:ea typeface="Source Serif 4 Bold" pitchFamily="34" charset="-122"/>
-                <a:cs typeface="Source Serif 4 Bold" pitchFamily="34" charset="-120"/>
-              </a:rPr>
-              <a:t>Hafta 14:</a:t>
-            </a:r>
-            <a:r>
-              <a:rPr lang="en-US" sz="1350" dirty="0">
-                <a:solidFill>
-                  <a:srgbClr val="504C49"/>
-                </a:solidFill>
-                <a:latin typeface="Source Serif 4" pitchFamily="34" charset="0"/>
-                <a:ea typeface="Source Serif 4" pitchFamily="34" charset="-122"/>
-                <a:cs typeface="Source Serif 4" pitchFamily="34" charset="-120"/>
-              </a:rPr>
-              <a:t> Proje Sunumları ve Code Review           </a:t>
-            </a:r>
-            <a:endParaRPr lang="en-US" sz="1350" dirty="0"/>
-          </a:p>
-          <a:p>
-            <a:pPr marL="274320" indent="-274320" algn="l">
-              <a:lnSpc>
-                <a:spcPct val="129000"/>
-              </a:lnSpc>
-              <a:buSzPct val="100000"/>
-              <a:buFont typeface="+mj-lt"/>
-              <a:buAutoNum type="arabicPeriod" startAt="11"/>
-            </a:pPr>
-            <a:r>
-              <a:rPr lang="en-US" sz="1350" dirty="0">
-                <a:solidFill>
-                  <a:srgbClr val="504C49"/>
-                </a:solidFill>
-                <a:latin typeface="Source Serif 4" pitchFamily="34" charset="0"/>
-                <a:ea typeface="Source Serif 4" pitchFamily="34" charset="-122"/>
-                <a:cs typeface="Source Serif 4" pitchFamily="34" charset="-120"/>
-              </a:rPr>
-              <a:t>             </a:t>
-            </a:r>
-            <a:r>
-              <a:rPr lang="en-US" sz="1350" b="1" dirty="0">
-                <a:solidFill>
-                  <a:srgbClr val="504C49"/>
-                </a:solidFill>
-                <a:latin typeface="Source Serif 4 Bold" pitchFamily="34" charset="0"/>
-                <a:ea typeface="Source Serif 4 Bold" pitchFamily="34" charset="-122"/>
-                <a:cs typeface="Source Serif 4 Bold" pitchFamily="34" charset="-120"/>
-              </a:rPr>
-              <a:t>Hafta 15:</a:t>
-            </a:r>
-            <a:r>
-              <a:rPr lang="en-US" sz="1350" dirty="0">
-                <a:solidFill>
-                  <a:srgbClr val="504C49"/>
-                </a:solidFill>
-                <a:latin typeface="Source Serif 4" pitchFamily="34" charset="0"/>
-                <a:ea typeface="Source Serif 4" pitchFamily="34" charset="-122"/>
-                <a:cs typeface="Source Serif 4" pitchFamily="34" charset="-120"/>
-              </a:rPr>
-              <a:t> FİNAL           </a:t>
-            </a:r>
-            <a:endParaRPr lang="en-US" sz="1350" dirty="0"/>
-          </a:p>
-        </p:txBody>
-      </p:sp>
-      <p:pic>
-        <p:nvPicPr>
-          <p:cNvPr id="8" name="Resim 7">
-            <a:extLst>
-              <a:ext uri="{FF2B5EF4-FFF2-40B4-BE49-F238E27FC236}">
-                <a16:creationId xmlns:a16="http://schemas.microsoft.com/office/drawing/2014/main" id="{3930611E-10F8-96A2-7BEF-8ABA2162A2EE}"/>
-              </a:ext>
-            </a:extLst>
-          </p:cNvPr>
-          <p:cNvPicPr>
-            <a:picLocks noChangeAspect="1"/>
-          </p:cNvPicPr>
-          <p:nvPr/>
-        </p:nvPicPr>
-        <p:blipFill>
-          <a:blip r:embed="rId3"/>
           <a:stretch>
             <a:fillRect/>
           </a:stretch>

</xml_diff>